<commit_message>
fix on the slide
</commit_message>
<xml_diff>
--- a/presentation/slide.pptx
+++ b/presentation/slide.pptx
@@ -109,6 +109,11 @@
       </a:defRPr>
     </a:lvl9pPr>
   </p:defaultTextStyle>
+  <p:extLst>
+    <p:ext uri="{EFAFB233-063F-42B5-8137-9DF3F51BA10A}">
+      <p15:sldGuideLst xmlns:p15="http://schemas.microsoft.com/office/powerpoint/2012/main"/>
+    </p:ext>
+  </p:extLst>
 </p:presentation>
 </file>
 
@@ -4138,8 +4143,8 @@
           </a:p>
         </p:txBody>
       </p:sp>
-      <mc:AlternateContent xmlns:mc="http://schemas.openxmlformats.org/markup-compatibility/2006">
-        <mc:Choice xmlns:a14="http://schemas.microsoft.com/office/drawing/2010/main" Requires="a14">
+      <mc:AlternateContent xmlns:mc="http://schemas.openxmlformats.org/markup-compatibility/2006" xmlns:a14="http://schemas.microsoft.com/office/drawing/2010/main">
+        <mc:Choice Requires="a14">
           <p:sp>
             <p:nvSpPr>
               <p:cNvPr id="14" name="ZoneTexte 13">
@@ -4168,6 +4173,7 @@
               </a:bodyPr>
               <a:lstStyle/>
               <a:p>
+                <a:pPr/>
                 <a14:m>
                   <m:oMathPara xmlns:m="http://schemas.openxmlformats.org/officeDocument/2006/math">
                     <m:oMath>
@@ -4289,7 +4295,7 @@
             </p:txBody>
           </p:sp>
         </mc:Choice>
-        <mc:Fallback>
+        <mc:Fallback xmlns="">
           <p:sp>
             <p:nvSpPr>
               <p:cNvPr id="14" name="ZoneTexte 13">
@@ -4369,8 +4375,8 @@
           </a:p>
         </p:txBody>
       </p:sp>
-      <mc:AlternateContent xmlns:mc="http://schemas.openxmlformats.org/markup-compatibility/2006">
-        <mc:Choice xmlns:a14="http://schemas.microsoft.com/office/drawing/2010/main" Requires="a14">
+      <mc:AlternateContent xmlns:mc="http://schemas.openxmlformats.org/markup-compatibility/2006" xmlns:a14="http://schemas.microsoft.com/office/drawing/2010/main">
+        <mc:Choice Requires="a14">
           <p:sp>
             <p:nvSpPr>
               <p:cNvPr id="17" name="ZoneTexte 16">
@@ -4399,6 +4405,7 @@
               </a:bodyPr>
               <a:lstStyle/>
               <a:p>
+                <a:pPr/>
                 <a14:m>
                   <m:oMathPara xmlns:m="http://schemas.openxmlformats.org/officeDocument/2006/math">
                     <m:oMath>
@@ -4536,6 +4543,7 @@
                 <a:endParaRPr lang="fr-FR" b="0" dirty="0"/>
               </a:p>
               <a:p>
+                <a:pPr/>
                 <a:br>
                   <a:rPr lang="fr-FR" b="0" dirty="0"/>
                 </a:br>
@@ -4641,6 +4649,7 @@
                 <a:endParaRPr lang="fr-FR" dirty="0"/>
               </a:p>
               <a:p>
+                <a:pPr/>
                 <a14:m>
                   <m:oMathPara xmlns:m="http://schemas.openxmlformats.org/officeDocument/2006/math">
                     <m:oMath>
@@ -4806,7 +4815,7 @@
             </p:txBody>
           </p:sp>
         </mc:Choice>
-        <mc:Fallback>
+        <mc:Fallback xmlns="">
           <p:sp>
             <p:nvSpPr>
               <p:cNvPr id="17" name="ZoneTexte 16">
@@ -5065,74 +5074,6 @@
       </p:sp>
       <p:sp>
         <p:nvSpPr>
-          <p:cNvPr id="2" name="ZoneTexte 1">
-            <a:extLst>
-              <a:ext uri="{FF2B5EF4-FFF2-40B4-BE49-F238E27FC236}">
-                <a16:creationId xmlns:a16="http://schemas.microsoft.com/office/drawing/2014/main" id="{1025C8C8-C64E-6147-4064-A3B02BFFC9FB}"/>
-              </a:ext>
-            </a:extLst>
-          </p:cNvPr>
-          <p:cNvSpPr txBox="1"/>
-          <p:nvPr/>
-        </p:nvSpPr>
-        <p:spPr>
-          <a:xfrm>
-            <a:off x="4465105" y="-650238"/>
-            <a:ext cx="3261790" cy="584775"/>
-          </a:xfrm>
-          <a:prstGeom prst="rect">
-            <a:avLst/>
-          </a:prstGeom>
-          <a:noFill/>
-        </p:spPr>
-        <p:txBody>
-          <a:bodyPr wrap="none" rtlCol="0">
-            <a:spAutoFit/>
-          </a:bodyPr>
-          <a:lstStyle/>
-          <a:p>
-            <a:r>
-              <a:rPr lang="fr-FR" sz="3200" b="1" u="sng" dirty="0">
-                <a:latin typeface="Segoe UI" panose="020B0502040204020203" pitchFamily="34" charset="0"/>
-                <a:cs typeface="Segoe UI" panose="020B0502040204020203" pitchFamily="34" charset="0"/>
-              </a:rPr>
-              <a:t>Tri par insertion</a:t>
-            </a:r>
-          </a:p>
-        </p:txBody>
-      </p:sp>
-      <p:pic>
-        <p:nvPicPr>
-          <p:cNvPr id="8" name="Image 7" descr="The provided text appears to be a snippet of a C++ function implementing the insertion sort algorithm, which is a simple sorting method.&#10;&#10;Le contenu généré par l’IA peut être incorrect.">
-            <a:extLst>
-              <a:ext uri="{FF2B5EF4-FFF2-40B4-BE49-F238E27FC236}">
-                <a16:creationId xmlns:a16="http://schemas.microsoft.com/office/drawing/2014/main" id="{0DE06905-6CDA-D583-EED8-99871518F8C4}"/>
-              </a:ext>
-            </a:extLst>
-          </p:cNvPr>
-          <p:cNvPicPr>
-            <a:picLocks noChangeAspect="1"/>
-          </p:cNvPicPr>
-          <p:nvPr/>
-        </p:nvPicPr>
-        <p:blipFill>
-          <a:blip r:embed="rId2"/>
-          <a:stretch>
-            <a:fillRect/>
-          </a:stretch>
-        </p:blipFill>
-        <p:spPr>
-          <a:xfrm>
-            <a:off x="12278558" y="1640311"/>
-            <a:ext cx="4457929" cy="4457929"/>
-          </a:xfrm>
-          <a:prstGeom prst="rect">
-            <a:avLst/>
-          </a:prstGeom>
-        </p:spPr>
-      </p:pic>
-      <p:sp>
-        <p:nvSpPr>
           <p:cNvPr id="7" name="ZoneTexte 6">
             <a:extLst>
               <a:ext uri="{FF2B5EF4-FFF2-40B4-BE49-F238E27FC236}">
@@ -5245,8 +5186,8 @@
           </a:p>
         </p:txBody>
       </p:sp>
-      <mc:AlternateContent xmlns:mc="http://schemas.openxmlformats.org/markup-compatibility/2006">
-        <mc:Choice xmlns:a14="http://schemas.microsoft.com/office/drawing/2010/main" Requires="a14">
+      <mc:AlternateContent xmlns:mc="http://schemas.openxmlformats.org/markup-compatibility/2006" xmlns:a14="http://schemas.microsoft.com/office/drawing/2010/main">
+        <mc:Choice Requires="a14">
           <p:sp>
             <p:nvSpPr>
               <p:cNvPr id="13" name="ZoneTexte 12">
@@ -5275,6 +5216,7 @@
               </a:bodyPr>
               <a:lstStyle/>
               <a:p>
+                <a:pPr/>
                 <a:r>
                   <a:rPr lang="fr-FR" dirty="0"/>
                   <a:t>Complexité : on passe une fois dans tous les sous-arbres donc</a:t>
@@ -5389,7 +5331,7 @@
             </p:txBody>
           </p:sp>
         </mc:Choice>
-        <mc:Fallback>
+        <mc:Fallback xmlns="">
           <p:sp>
             <p:nvSpPr>
               <p:cNvPr id="13" name="ZoneTexte 12">
@@ -6862,74 +6804,6 @@
       </p:sp>
       <p:sp>
         <p:nvSpPr>
-          <p:cNvPr id="2" name="ZoneTexte 1">
-            <a:extLst>
-              <a:ext uri="{FF2B5EF4-FFF2-40B4-BE49-F238E27FC236}">
-                <a16:creationId xmlns:a16="http://schemas.microsoft.com/office/drawing/2014/main" id="{7DE78CB0-A339-6C09-20E3-EFDF0C3A142C}"/>
-              </a:ext>
-            </a:extLst>
-          </p:cNvPr>
-          <p:cNvSpPr txBox="1"/>
-          <p:nvPr/>
-        </p:nvSpPr>
-        <p:spPr>
-          <a:xfrm>
-            <a:off x="4465105" y="-650238"/>
-            <a:ext cx="3261790" cy="584775"/>
-          </a:xfrm>
-          <a:prstGeom prst="rect">
-            <a:avLst/>
-          </a:prstGeom>
-          <a:noFill/>
-        </p:spPr>
-        <p:txBody>
-          <a:bodyPr wrap="none" rtlCol="0">
-            <a:spAutoFit/>
-          </a:bodyPr>
-          <a:lstStyle/>
-          <a:p>
-            <a:r>
-              <a:rPr lang="fr-FR" sz="3200" b="1" u="sng" dirty="0">
-                <a:latin typeface="Segoe UI" panose="020B0502040204020203" pitchFamily="34" charset="0"/>
-                <a:cs typeface="Segoe UI" panose="020B0502040204020203" pitchFamily="34" charset="0"/>
-              </a:rPr>
-              <a:t>Tri par insertion</a:t>
-            </a:r>
-          </a:p>
-        </p:txBody>
-      </p:sp>
-      <p:pic>
-        <p:nvPicPr>
-          <p:cNvPr id="8" name="Image 7" descr="The provided text appears to be a snippet of a C++ function implementing the insertion sort algorithm, which is a simple sorting method.&#10;&#10;Le contenu généré par l’IA peut être incorrect.">
-            <a:extLst>
-              <a:ext uri="{FF2B5EF4-FFF2-40B4-BE49-F238E27FC236}">
-                <a16:creationId xmlns:a16="http://schemas.microsoft.com/office/drawing/2014/main" id="{B24CD069-ED04-E3E7-1C24-27D8B3FAE727}"/>
-              </a:ext>
-            </a:extLst>
-          </p:cNvPr>
-          <p:cNvPicPr>
-            <a:picLocks noChangeAspect="1"/>
-          </p:cNvPicPr>
-          <p:nvPr/>
-        </p:nvPicPr>
-        <p:blipFill>
-          <a:blip r:embed="rId2"/>
-          <a:stretch>
-            <a:fillRect/>
-          </a:stretch>
-        </p:blipFill>
-        <p:spPr>
-          <a:xfrm>
-            <a:off x="12278558" y="1640311"/>
-            <a:ext cx="4457929" cy="4457929"/>
-          </a:xfrm>
-          <a:prstGeom prst="rect">
-            <a:avLst/>
-          </a:prstGeom>
-        </p:spPr>
-      </p:pic>
-      <p:sp>
-        <p:nvSpPr>
           <p:cNvPr id="7" name="ZoneTexte 6">
             <a:extLst>
               <a:ext uri="{FF2B5EF4-FFF2-40B4-BE49-F238E27FC236}">
@@ -8139,74 +8013,6 @@
       </p:sp>
       <p:sp>
         <p:nvSpPr>
-          <p:cNvPr id="2" name="ZoneTexte 1">
-            <a:extLst>
-              <a:ext uri="{FF2B5EF4-FFF2-40B4-BE49-F238E27FC236}">
-                <a16:creationId xmlns:a16="http://schemas.microsoft.com/office/drawing/2014/main" id="{041020DC-2399-FA87-AB7B-147FC6A1DD1E}"/>
-              </a:ext>
-            </a:extLst>
-          </p:cNvPr>
-          <p:cNvSpPr txBox="1"/>
-          <p:nvPr/>
-        </p:nvSpPr>
-        <p:spPr>
-          <a:xfrm>
-            <a:off x="4465105" y="-650238"/>
-            <a:ext cx="3261790" cy="584775"/>
-          </a:xfrm>
-          <a:prstGeom prst="rect">
-            <a:avLst/>
-          </a:prstGeom>
-          <a:noFill/>
-        </p:spPr>
-        <p:txBody>
-          <a:bodyPr wrap="none" rtlCol="0">
-            <a:spAutoFit/>
-          </a:bodyPr>
-          <a:lstStyle/>
-          <a:p>
-            <a:r>
-              <a:rPr lang="fr-FR" sz="3200" b="1" u="sng" dirty="0">
-                <a:latin typeface="Segoe UI" panose="020B0502040204020203" pitchFamily="34" charset="0"/>
-                <a:cs typeface="Segoe UI" panose="020B0502040204020203" pitchFamily="34" charset="0"/>
-              </a:rPr>
-              <a:t>Tri par insertion</a:t>
-            </a:r>
-          </a:p>
-        </p:txBody>
-      </p:sp>
-      <p:pic>
-        <p:nvPicPr>
-          <p:cNvPr id="8" name="Image 7" descr="The provided text appears to be a snippet of a C++ function implementing the insertion sort algorithm, which is a simple sorting method.&#10;&#10;Le contenu généré par l’IA peut être incorrect.">
-            <a:extLst>
-              <a:ext uri="{FF2B5EF4-FFF2-40B4-BE49-F238E27FC236}">
-                <a16:creationId xmlns:a16="http://schemas.microsoft.com/office/drawing/2014/main" id="{C6AE7469-5A6B-CD51-CDFF-D45F5284BF4A}"/>
-              </a:ext>
-            </a:extLst>
-          </p:cNvPr>
-          <p:cNvPicPr>
-            <a:picLocks noChangeAspect="1"/>
-          </p:cNvPicPr>
-          <p:nvPr/>
-        </p:nvPicPr>
-        <p:blipFill>
-          <a:blip r:embed="rId2"/>
-          <a:stretch>
-            <a:fillRect/>
-          </a:stretch>
-        </p:blipFill>
-        <p:spPr>
-          <a:xfrm>
-            <a:off x="12278558" y="1640311"/>
-            <a:ext cx="4457929" cy="4457929"/>
-          </a:xfrm>
-          <a:prstGeom prst="rect">
-            <a:avLst/>
-          </a:prstGeom>
-        </p:spPr>
-      </p:pic>
-      <p:sp>
-        <p:nvSpPr>
           <p:cNvPr id="7" name="ZoneTexte 6">
             <a:extLst>
               <a:ext uri="{FF2B5EF4-FFF2-40B4-BE49-F238E27FC236}">
@@ -8281,8 +8087,8 @@
           </a:p>
         </p:txBody>
       </p:sp>
-      <mc:AlternateContent xmlns:mc="http://schemas.openxmlformats.org/markup-compatibility/2006">
-        <mc:Choice xmlns:a14="http://schemas.microsoft.com/office/drawing/2010/main" Requires="a14">
+      <mc:AlternateContent xmlns:mc="http://schemas.openxmlformats.org/markup-compatibility/2006" xmlns:a14="http://schemas.microsoft.com/office/drawing/2010/main">
+        <mc:Choice Requires="a14">
           <p:sp>
             <p:nvSpPr>
               <p:cNvPr id="13" name="ZoneTexte 12">
@@ -8311,6 +8117,7 @@
               </a:bodyPr>
               <a:lstStyle/>
               <a:p>
+                <a:pPr/>
                 <a14:m>
                   <m:oMathPara xmlns:m="http://schemas.openxmlformats.org/officeDocument/2006/math">
                     <m:oMath>
@@ -8494,7 +8301,7 @@
             </p:txBody>
           </p:sp>
         </mc:Choice>
-        <mc:Fallback>
+        <mc:Fallback xmlns="">
           <p:sp>
             <p:nvSpPr>
               <p:cNvPr id="13" name="ZoneTexte 12">
@@ -8539,8 +8346,8 @@
           </p:sp>
         </mc:Fallback>
       </mc:AlternateContent>
-      <mc:AlternateContent xmlns:mc="http://schemas.openxmlformats.org/markup-compatibility/2006">
-        <mc:Choice xmlns:a14="http://schemas.microsoft.com/office/drawing/2010/main" Requires="a14">
+      <mc:AlternateContent xmlns:mc="http://schemas.openxmlformats.org/markup-compatibility/2006" xmlns:a14="http://schemas.microsoft.com/office/drawing/2010/main">
+        <mc:Choice Requires="a14">
           <p:sp>
             <p:nvSpPr>
               <p:cNvPr id="19" name="ZoneTexte 18">
@@ -8661,7 +8468,7 @@
             </p:txBody>
           </p:sp>
         </mc:Choice>
-        <mc:Fallback>
+        <mc:Fallback xmlns="">
           <p:sp>
             <p:nvSpPr>
               <p:cNvPr id="19" name="ZoneTexte 18">

</xml_diff>